<commit_message>
Lecture 11: upgrade Quiz 11 Q4 to a decide beat; drop read-off filler
Active-learning review pass:
- Q4 was 'why must the two views agree?' — restating the invariance principle
  taught one slide earlier (recall). Upgrade to a DECIDE: mark four augmentations
  SAFE/CORRUPT for contrastive pretraining ((a) intensity noise, (b) m/z 0.2 Da,
  (c) swap in a DIFFERENT patient's spectrum, (d) x1.05 scale) — (c) corrupts
  because it changes the real sample, forcing agreement teaches the model to
  ignore real biological differences. Lands the 'augmentations must preserve the
  biology' guardrail. Slide 16 + quiz11 Q4 rewritten; recap/notes Q4 refs synced.
- Drop the slide-10 read-off filler ('does the LEFT peak grow or shrink?' — the
  morph figure shows it) but keep the interpolation teaching (core VAE payoff,
  Lab 4 preview). Deck stays 21 slides; checkers pass, quiz compiles.
</commit_message>
<xml_diff>
--- a/slides/pptx/lecture11_unsupervised.pptx
+++ b/slides/pptx/lecture11_unsupervised.pptx
@@ -522,7 +522,7 @@
           <a:lstStyle/>
           <a:p>
             <a:r>
-              <a:t>Monday afternoon, Segment 4 hour two, straight on from Lecture 10's "your data, your metrics." Here is the uncomfortable truth for a clinical lab: most of your data is UNLABELED — thousands of QC runs, spectra, chromatograms nobody ever annotated. This hour is about what you can still learn without labels. Four stops: (1) autoencoders — compress then reconstruct, and use the reconstruction error as an anomaly / QC score; (2) VAEs, intuitively — points vs. clouds, told entirely in pictures with NO derivation; (3) self-supervised learning — how foundation models pretrain by letting the data label itself (masking, contrastive, DINO); (4) semi-supervised in one slide — the "10,000 unlabeled + 100 labeled" pseudo-labeling middle path. The topic is conceptual, so the one numeric beat is reconstruction error: an MSE by hand, then a normal-vs-anomaly decision against a threshold — a straight callback to Lecture 10's sensitivity/specificity choice. Same interactive spine as every lecture: each I-do is followed by a you-do that IS a Quiz 11 item. Hand out Quiz 11 now, blank; we hit all four items live — the two latent pictures (Q1), the four-way paradigm match (Q2), the reconstruction-error compute (Q3), and the DINO/contrastive "why must the views agree?" (Q4). Lab 4 next hour builds a VAE on real spectra, so everything here is the on-ramp.</a:t>
+              <a:t>Monday afternoon, Segment 4 hour two, straight on from Lecture 10's "your data, your metrics." Here is the uncomfortable truth for a clinical lab: most of your data is UNLABELED — thousands of QC runs, spectra, chromatograms nobody ever annotated. This hour is about what you can still learn without labels. Four stops: (1) autoencoders — compress then reconstruct, and use the reconstruction error as an anomaly / QC score; (2) VAEs, intuitively — points vs. clouds, told entirely in pictures with NO derivation; (3) self-supervised learning — how foundation models pretrain by letting the data label itself (masking, contrastive, DINO); (4) semi-supervised in one slide — the "10,000 unlabeled + 100 labeled" pseudo-labeling middle path. The topic is conceptual, so the one numeric beat is reconstruction error: an MSE by hand, then a normal-vs-anomaly decision against a threshold — a straight callback to Lecture 10's sensitivity/specificity choice. Same interactive spine as every lecture: each I-do is followed by a you-do that IS a Quiz 11 item. Hand out Quiz 11 now, blank; we hit all four items live — the two latent pictures (Q1), the four-way paradigm match (Q2), the reconstruction-error compute (Q3), and the DINO/contrastive safe-vs-corrupt augmentation call (Q4). Lab 4 next hour builds a VAE on real spectra, so everything here is the on-ramp.</a:t>
             </a:r>
           </a:p>
           <a:p/>
@@ -593,7 +593,7 @@
           <a:lstStyle/>
           <a:p>
             <a:r>
-              <a:t>The fun payoff and the clearest proof the cloud is smooth. Take two real spectra, A and B; encode each to its latent code; then walk a straight line between those two codes and decode a handful of stops along the way. The decoded spectra MORPH continuously — peaks slide in m/z and trade height as you move from A to B — a smooth interpolation, not an abrupt switch. The teaching point: this is only possible because the VAE's latent cloud is gap-free, so every intermediate point on the line is a valid, plausible spectrum. Try the same walk in a plain autoencoder's latent space and somewhere in the middle you cross an empty gap the decoder was never trained on, and out comes garbage. This is exactly the Lab 4 "fun payoff" cell — sample latent points and interpolate between two spectra — so it's a direct preview. 💬 DO-IT-TOGETHER (30 sec, to break the VAE stretch): walking stop 1 → stop 5, the LEFT peak SHRINKS — it starts tall at stop 1 (spectrum A) and is clearly lower by stop 5 (spectrum B), while the middle peak rises; that continuous trade of peak heights IS the smooth morph the gap-free cloud buys you. Take the call, then next slide the room makes the AE-vs-VAE identification itself (Quiz 11 Q1).</a:t>
+              <a:t>The fun payoff and the clearest proof the cloud is smooth. Take two real spectra, A and B; encode each to its latent code; then walk a straight line between those two codes and decode a handful of stops along the way. The decoded spectra MORPH continuously — peaks slide in m/z and trade height as you move from A to B — a smooth interpolation, not an abrupt switch. The teaching point: this is only possible because the VAE's latent cloud is gap-free, so every intermediate point on the line is a valid, plausible spectrum. Try the same walk in a plain autoencoder's latent space and somewhere in the middle you cross an empty gap the decoder was never trained on, and out comes garbage. This is exactly the Lab 4 "fun payoff" cell — sample latent points and interpolate between two spectra — so it's a direct preview. Next slide the room makes the AE-vs-VAE identification itself (Quiz 11 Q1).</a:t>
             </a:r>
           </a:p>
           <a:p/>
@@ -948,7 +948,7 @@
           <a:lstStyle/>
           <a:p>
             <a:r>
-              <a:t>The third self-supervised flavor and the one with the striking visual: DINO (self-DIstillation with NO labels, Caron et al. 2021). It runs on the same "two views must agree" principle as contrastive learning, packaged as a student and a teacher. Two augmented views of one input are fed to a STUDENT network and a TEACHER network; the student is trained so its output distribution MATCHES the teacher's on the same input. Where does the teacher come from with no labels? It IS the student — a slow moving average of the student's own weights — so the model teaches itself, which is why it's called self-distillation. The famous, almost eerie payoff (right panel): after this label-free pretraining, the model's ATTENTION spontaneously highlights the main object in an image — unsupervised segmentation, no masks or boxes ever provided. For us the message is the through-line of the whole self-supervised section: augmentation-invariance — make different views of the same thing agree — plus scale is enough to learn powerful, general features without labels, which is how modern foundation models pretrain (forward to Lecture 13). Next slide the room answers WHY the views must agree (Quiz 11 Q4).</a:t>
+              <a:t>The third self-supervised flavor and the one with the striking visual: DINO (self-DIstillation with NO labels, Caron et al. 2021). It runs on the same "two views must agree" principle as contrastive learning, packaged as a student and a teacher. Two augmented views of one input are fed to a STUDENT network and a TEACHER network; the student is trained so its output distribution MATCHES the teacher's on the same input. Where does the teacher come from with no labels? It IS the student — a slow moving average of the student's own weights — so the model teaches itself, which is why it's called self-distillation. The famous, almost eerie payoff (right panel): after this label-free pretraining, the model's ATTENTION spontaneously highlights the main object in an image — unsupervised segmentation, no masks or boxes ever provided. For us the message is the through-line of the whole self-supervised section: augmentation-invariance — make different views of the same thing agree — plus scale is enough to learn powerful, general features without labels, which is how modern foundation models pretrain (forward to Lecture 13). Next slide the room decides WHICH augmentation would corrupt this agreement — a spot-the-break DECIDE, not a definition restated (Quiz 11 Q4).</a:t>
             </a:r>
           </a:p>
           <a:p/>
@@ -1019,7 +1019,7 @@
           <a:lstStyle/>
           <a:p>
             <a:r>
-              <a:t>YOU-DO = Quiz 11 Q4 (the contrastive/DINO intuition; assesses the self-supervised outcome). Expected answer (any equivalent phrasing earns full credit): the two views differ only by nuisance augmentations — added noise, an m/z shift — while the underlying sample is identical, so forcing their embeddings to AGREE makes the model learn the stable, real content and IGNORE the nuisance variation (augmentation-invariance). A good extension: that invariance is exactly what you want for spectra, because the same sample on a different day or instrument should still land in the same place. And note the guardrail — the augmentations must preserve the biology; if a "view" changed the actual signal, forcing agreement would teach the model to ignore something real. Take one answer from the floor, then have them fill Q4. That's the third and fourth Quiz 11 items done — one more paradigm to name.</a:t>
+              <a:t>YOU-DO = Quiz 11 Q4 (a DECIDE beat, not "restate the definition": the room must spot which augmentation breaks the trick). Answer: (c) is CORRUPT; (a), (b), (d) are safe. The safe three add only the NUISANCE variation the SAME sample would show run-to-run — detector noise, a small m/z calibration drift, a global intensity rescale — so forcing those views to agree makes the model ignore the nuisance and keep the real content (augmentation-invariance, the whole point of contrastive/DINO). But (c) swaps in a GENUINELY DIFFERENT sample: forcing its embedding to match would teach the model to ignore real biological differences — it would treat two different patients as identical. The durable rule the beat lands: augmentations must preserve the underlying biology, or agreement teaches the model to throw away something real. Take one SAFE/CORRUPT call with its reason, then have them fill Q4 — that's the fourth Quiz 11 item; one more paradigm to name.</a:t>
             </a:r>
           </a:p>
           <a:p/>
@@ -1374,7 +1374,7 @@
           <a:lstStyle/>
           <a:p>
             <a:r>
-              <a:t>Recap = the Lecture 11 outcomes, each already exercised this hour and tied to a Quiz 11 item: the autoencoder + reconstruction-error compute (Q3), the AE-vs-VAE latent picture (Q1), the four-paradigm match (Q2), and the self-supervised "views must agree" intuition (Q4). The sheet was done across the hour, not as an end block — a distributed worksheet. Frame the takeaway: most lab data is unlabeled, and you now have a menu for it — reconstruct to denoise or flag anomalies, learn a smooth latent to sample and interpolate, let the data label itself to pretrain a body, or bridge a few labels to many with pseudo-labeling. Keep the sheet as the on-ramp to Lab 4.</a:t>
+              <a:t>Recap = the Lecture 11 outcomes, each already exercised this hour and tied to a Quiz 11 item: the autoencoder + reconstruction-error compute (Q3), the AE-vs-VAE latent picture (Q1), the four-paradigm match (Q2), and the self-supervised safe-vs-corrupt augmentation decide (Q4). The sheet was done across the hour, not as an end block — a distributed worksheet. Frame the takeaway: most lab data is unlabeled, and you now have a menu for it — reconstruct to denoise or flag anomalies, learn a smooth latent to sample and interpolate, let the data label itself to pretrain a body, or bridge a few labels to many with pseudo-labeling. Keep the sheet as the on-ramp to Lab 4.</a:t>
             </a:r>
           </a:p>
           <a:p/>
@@ -5267,8 +5267,8 @@
         </p:blipFill>
         <p:spPr>
           <a:xfrm>
-            <a:off x="3518240" y="1828800"/>
-            <a:ext cx="5125039" cy="2840736"/>
+            <a:off x="3050827" y="1828800"/>
+            <a:ext cx="6059865" cy="3358897"/>
           </a:xfrm>
           <a:prstGeom prst="rect">
             <a:avLst/>
@@ -5283,8 +5283,8 @@
         </p:nvSpPr>
         <p:spPr>
           <a:xfrm>
-            <a:off x="548640" y="4760976"/>
-            <a:ext cx="10515600" cy="1959864"/>
+            <a:off x="548640" y="5279137"/>
+            <a:ext cx="10515600" cy="1441703"/>
           </a:xfrm>
           <a:prstGeom prst="rect">
             <a:avLst/>
@@ -5334,7 +5334,7 @@
                 </a:solidFill>
                 <a:latin typeface="Avenir Next"/>
               </a:rPr>
-              <a:t>Pick two real spectra, A and B, find their latent codes, and walk a straight line between them. Decoding each stop gives a smooth MORPH — peaks slide and swap height from A into B. This only works because the VAE cloud is gap-free: every stop on the line is a valid, plausible spectrum. An AE's gaps would decode to garbage partway across.  💬 30 sec with your neighbor: walking stop 1 (A) → stop 5 (B), does the LEFT peak grow or shrink? (Answer in notes: it shrinks, 1.0 → 0.4, smoothly — every stop is a valid spectrum.)</a:t>
+              <a:t>Pick two real spectra, A and B, find their latent codes, and walk a straight line between them. Decoding each stop gives a smooth MORPH — peaks slide and swap height from A into B. This only works because the VAE cloud is gap-free: every stop on the line is a valid, plausible spectrum. An AE's gaps would decode to garbage partway across.</a:t>
             </a:r>
           </a:p>
         </p:txBody>
@@ -6532,7 +6532,7 @@
         <p:spPr>
           <a:xfrm>
             <a:off x="548640" y="731520"/>
-            <a:ext cx="11064240" cy="1005840"/>
+            <a:ext cx="11064240" cy="1127760"/>
           </a:xfrm>
           <a:prstGeom prst="rect">
             <a:avLst/>
@@ -6552,7 +6552,7 @@
                 </a:solidFill>
                 <a:latin typeface="Avenir Next"/>
               </a:rPr>
-              <a:t>Your turn — why must the two views agree?</a:t>
+              <a:t>Your turn — which augmentation would corrupt it?</a:t>
             </a:r>
           </a:p>
         </p:txBody>
@@ -6573,8 +6573,8 @@
         </p:blipFill>
         <p:spPr>
           <a:xfrm>
-            <a:off x="1666415" y="1828800"/>
-            <a:ext cx="8828689" cy="3840479"/>
+            <a:off x="2517753" y="1828800"/>
+            <a:ext cx="7126013" cy="3099816"/>
           </a:xfrm>
           <a:prstGeom prst="rect">
             <a:avLst/>
@@ -6589,8 +6589,8 @@
         </p:nvSpPr>
         <p:spPr>
           <a:xfrm>
-            <a:off x="548640" y="5760719"/>
-            <a:ext cx="10515600" cy="923544"/>
+            <a:off x="548640" y="5020056"/>
+            <a:ext cx="10515600" cy="1700784"/>
           </a:xfrm>
           <a:prstGeom prst="rect">
             <a:avLst/>
@@ -6640,7 +6640,7 @@
                 </a:solidFill>
                 <a:latin typeface="Avenir Next"/>
               </a:rPr>
-              <a:t>Your turn → Quiz 11, Q4. Two augmented views of the SAME spectrum are forced to land together. In one sentence: WHY must they agree — what does that force the model to learn? Worked answer in the notes.</a:t>
+              <a:t>Your turn → Quiz 11, Q4. Contrastive pretraining forces two augmented VIEWS of the same spectrum to land together. Three augmentations are fine, ONE corrupts it — mark each SAFE or CORRUPT: (a) add intensity noise · (b) shift m/z 0.2 Da · (c) swap in a DIFFERENT patient's spectrum · (d) scale intensities ×1.05. Which is corrupt, and what would forcing agreement then teach the model? Worked answer in the notes.</a:t>
             </a:r>
           </a:p>
         </p:txBody>
@@ -7718,7 +7718,7 @@
         <p:spPr>
           <a:xfrm>
             <a:off x="548640" y="1920240"/>
-            <a:ext cx="10789920" cy="3566159"/>
+            <a:ext cx="10789920" cy="3611880"/>
           </a:xfrm>
           <a:prstGeom prst="rect">
             <a:avLst/>
@@ -7737,7 +7737,7 @@
               </a:spcAft>
             </a:pPr>
             <a:r>
-              <a:rPr sz="2100" b="1" i="0">
+              <a:rPr sz="1900" b="1" i="0">
                 <a:solidFill>
                   <a:srgbClr val="0E7C7B"/>
                 </a:solidFill>
@@ -7746,7 +7746,7 @@
               <a:t>•  </a:t>
             </a:r>
             <a:r>
-              <a:rPr sz="2100" b="0" i="0">
+              <a:rPr sz="1900" b="0" i="0">
                 <a:solidFill>
                   <a:srgbClr val="1B2025"/>
                 </a:solidFill>
@@ -7762,7 +7762,7 @@
               </a:spcAft>
             </a:pPr>
             <a:r>
-              <a:rPr sz="2100" b="1" i="0">
+              <a:rPr sz="1900" b="1" i="0">
                 <a:solidFill>
                   <a:srgbClr val="0E7C7B"/>
                 </a:solidFill>
@@ -7771,7 +7771,7 @@
               <a:t>•  </a:t>
             </a:r>
             <a:r>
-              <a:rPr sz="2100" b="0" i="0">
+              <a:rPr sz="1900" b="0" i="0">
                 <a:solidFill>
                   <a:srgbClr val="1B2025"/>
                 </a:solidFill>
@@ -7787,7 +7787,7 @@
               </a:spcAft>
             </a:pPr>
             <a:r>
-              <a:rPr sz="2100" b="1" i="0">
+              <a:rPr sz="1900" b="1" i="0">
                 <a:solidFill>
                   <a:srgbClr val="0E7C7B"/>
                 </a:solidFill>
@@ -7796,7 +7796,7 @@
               <a:t>•  </a:t>
             </a:r>
             <a:r>
-              <a:rPr sz="2100" b="0" i="0">
+              <a:rPr sz="1900" b="0" i="0">
                 <a:solidFill>
                   <a:srgbClr val="1B2025"/>
                 </a:solidFill>
@@ -7812,7 +7812,7 @@
               </a:spcAft>
             </a:pPr>
             <a:r>
-              <a:rPr sz="2100" b="1" i="0">
+              <a:rPr sz="1900" b="1" i="0">
                 <a:solidFill>
                   <a:srgbClr val="0E7C7B"/>
                 </a:solidFill>
@@ -7821,13 +7821,13 @@
               <a:t>•  </a:t>
             </a:r>
             <a:r>
-              <a:rPr sz="2100" b="0" i="0">
+              <a:rPr sz="1900" b="0" i="0">
                 <a:solidFill>
                   <a:srgbClr val="1B2025"/>
                 </a:solidFill>
                 <a:latin typeface="Avenir Next"/>
               </a:rPr>
-              <a:t>Name the four paradigms and why self-supervised views must agree (Quiz 11 Q2 &amp; Q4) — and that semi-supervised pseudo-labeling exists</a:t>
+              <a:t>Name the four paradigms, and spot which augmentation would corrupt self-supervised pretraining — augmentations must preserve the biology (Quiz 11 Q2 &amp; Q4)</a:t>
             </a:r>
           </a:p>
         </p:txBody>
@@ -7882,7 +7882,7 @@
                 </a:solidFill>
                 <a:latin typeface="Avenir Next"/>
               </a:rPr>
-              <a:t>You have now worked every item on Quiz 11 live — the reconstruction-error compute (Q3), the two latent pictures (Q1), the four-way paradigm match (Q2), and the DINO/contrastive 'why agree?' (Q4). Keep the sheet — Lab 4 builds a VAE on real spectra.</a:t>
+              <a:t>You have now worked every item on Quiz 11 live — the reconstruction-error compute (Q3), the two latent pictures (Q1), the four-way paradigm match (Q2), and the safe-vs-corrupt augmentation call (Q4). Keep the sheet — Lab 4 builds a VAE on real spectra.</a:t>
             </a:r>
           </a:p>
         </p:txBody>

</xml_diff>